<commit_message>
Update 耶穌在我裡面_Giê-xu ở trong tôi.pptx
</commit_message>
<xml_diff>
--- a/中越詩歌/耶穌在我裡面_Giê-xu ở trong tôi.pptx
+++ b/中越詩歌/耶穌在我裡面_Giê-xu ở trong tôi.pptx
@@ -309,7 +309,7 @@
           <a:p>
             <a:fld id="{4708DAAA-A60A-4649-A77A-7F12CC5C96A6}" type="datetimeFigureOut">
               <a:rPr lang="vi-VN" smtClean="0"/>
-              <a:t>01/08/2022</a:t>
+              <a:t>13/09/2026</a:t>
             </a:fld>
             <a:endParaRPr lang="vi-VN"/>
           </a:p>
@@ -479,7 +479,7 @@
           <a:p>
             <a:fld id="{4708DAAA-A60A-4649-A77A-7F12CC5C96A6}" type="datetimeFigureOut">
               <a:rPr lang="vi-VN" smtClean="0"/>
-              <a:t>01/08/2022</a:t>
+              <a:t>13/09/2026</a:t>
             </a:fld>
             <a:endParaRPr lang="vi-VN"/>
           </a:p>
@@ -659,7 +659,7 @@
           <a:p>
             <a:fld id="{4708DAAA-A60A-4649-A77A-7F12CC5C96A6}" type="datetimeFigureOut">
               <a:rPr lang="vi-VN" smtClean="0"/>
-              <a:t>01/08/2022</a:t>
+              <a:t>13/09/2026</a:t>
             </a:fld>
             <a:endParaRPr lang="vi-VN"/>
           </a:p>
@@ -829,7 +829,7 @@
           <a:p>
             <a:fld id="{4708DAAA-A60A-4649-A77A-7F12CC5C96A6}" type="datetimeFigureOut">
               <a:rPr lang="vi-VN" smtClean="0"/>
-              <a:t>01/08/2022</a:t>
+              <a:t>13/09/2026</a:t>
             </a:fld>
             <a:endParaRPr lang="vi-VN"/>
           </a:p>
@@ -1075,7 +1075,7 @@
           <a:p>
             <a:fld id="{4708DAAA-A60A-4649-A77A-7F12CC5C96A6}" type="datetimeFigureOut">
               <a:rPr lang="vi-VN" smtClean="0"/>
-              <a:t>01/08/2022</a:t>
+              <a:t>13/09/2026</a:t>
             </a:fld>
             <a:endParaRPr lang="vi-VN"/>
           </a:p>
@@ -1363,7 +1363,7 @@
           <a:p>
             <a:fld id="{4708DAAA-A60A-4649-A77A-7F12CC5C96A6}" type="datetimeFigureOut">
               <a:rPr lang="vi-VN" smtClean="0"/>
-              <a:t>01/08/2022</a:t>
+              <a:t>13/09/2026</a:t>
             </a:fld>
             <a:endParaRPr lang="vi-VN"/>
           </a:p>
@@ -1785,7 +1785,7 @@
           <a:p>
             <a:fld id="{4708DAAA-A60A-4649-A77A-7F12CC5C96A6}" type="datetimeFigureOut">
               <a:rPr lang="vi-VN" smtClean="0"/>
-              <a:t>01/08/2022</a:t>
+              <a:t>13/09/2026</a:t>
             </a:fld>
             <a:endParaRPr lang="vi-VN"/>
           </a:p>
@@ -1903,7 +1903,7 @@
           <a:p>
             <a:fld id="{4708DAAA-A60A-4649-A77A-7F12CC5C96A6}" type="datetimeFigureOut">
               <a:rPr lang="vi-VN" smtClean="0"/>
-              <a:t>01/08/2022</a:t>
+              <a:t>13/09/2026</a:t>
             </a:fld>
             <a:endParaRPr lang="vi-VN"/>
           </a:p>
@@ -1998,7 +1998,7 @@
           <a:p>
             <a:fld id="{4708DAAA-A60A-4649-A77A-7F12CC5C96A6}" type="datetimeFigureOut">
               <a:rPr lang="vi-VN" smtClean="0"/>
-              <a:t>01/08/2022</a:t>
+              <a:t>13/09/2026</a:t>
             </a:fld>
             <a:endParaRPr lang="vi-VN"/>
           </a:p>
@@ -2275,7 +2275,7 @@
           <a:p>
             <a:fld id="{4708DAAA-A60A-4649-A77A-7F12CC5C96A6}" type="datetimeFigureOut">
               <a:rPr lang="vi-VN" smtClean="0"/>
-              <a:t>01/08/2022</a:t>
+              <a:t>13/09/2026</a:t>
             </a:fld>
             <a:endParaRPr lang="vi-VN"/>
           </a:p>
@@ -2532,7 +2532,7 @@
           <a:p>
             <a:fld id="{4708DAAA-A60A-4649-A77A-7F12CC5C96A6}" type="datetimeFigureOut">
               <a:rPr lang="vi-VN" smtClean="0"/>
-              <a:t>01/08/2022</a:t>
+              <a:t>13/09/2026</a:t>
             </a:fld>
             <a:endParaRPr lang="vi-VN"/>
           </a:p>
@@ -2750,7 +2750,7 @@
           <a:p>
             <a:fld id="{4708DAAA-A60A-4649-A77A-7F12CC5C96A6}" type="datetimeFigureOut">
               <a:rPr lang="vi-VN" smtClean="0"/>
-              <a:t>01/08/2022</a:t>
+              <a:t>13/09/2026</a:t>
             </a:fld>
             <a:endParaRPr lang="vi-VN"/>
           </a:p>
@@ -3753,7 +3753,7 @@
                 <a:latin typeface="Microsoft JhengHei" panose="020B0604030504040204" pitchFamily="34" charset="-120"/>
                 <a:ea typeface="Microsoft JhengHei" panose="020B0604030504040204" pitchFamily="34" charset="-120"/>
               </a:rPr>
-              <a:t>副</a:t>
+              <a:t>副歌</a:t>
             </a:r>
             <a:r>
               <a:rPr lang="en-US" sz="4267" b="1" dirty="0" smtClean="0">
@@ -4162,49 +4162,35 @@
                 <a:solidFill>
                   <a:srgbClr val="000066"/>
                 </a:solidFill>
-                <a:effectLst/>
                 <a:latin typeface="Microsoft JhengHei" panose="020B0604030504040204" pitchFamily="34" charset="-120"/>
                 <a:ea typeface="Microsoft JhengHei" panose="020B0604030504040204" pitchFamily="34" charset="-120"/>
               </a:rPr>
               <a:t>( </a:t>
             </a:r>
             <a:r>
-              <a:rPr lang="zh-CN" altLang="en-US" sz="4267" b="1" dirty="0" smtClean="0">
+              <a:rPr lang="zh-CN" altLang="en-US" sz="4267" b="1" dirty="0">
                 <a:solidFill>
                   <a:srgbClr val="000066"/>
                 </a:solidFill>
                 <a:latin typeface="Microsoft JhengHei" panose="020B0604030504040204" pitchFamily="34" charset="-120"/>
                 <a:ea typeface="Microsoft JhengHei" panose="020B0604030504040204" pitchFamily="34" charset="-120"/>
               </a:rPr>
-              <a:t>副</a:t>
-            </a:r>
-            <a:r>
-              <a:rPr lang="en-US" sz="4267" b="1" dirty="0" smtClean="0">
+              <a:t>副歌</a:t>
+            </a:r>
+            <a:r>
+              <a:rPr lang="en-US" sz="4267" b="1" dirty="0">
                 <a:solidFill>
                   <a:srgbClr val="000066"/>
                 </a:solidFill>
-                <a:effectLst/>
                 <a:latin typeface="Microsoft JhengHei" panose="020B0604030504040204" pitchFamily="34" charset="-120"/>
                 <a:ea typeface="Microsoft JhengHei" panose="020B0604030504040204" pitchFamily="34" charset="-120"/>
               </a:rPr>
-              <a:t> </a:t>
-            </a:r>
-            <a:r>
-              <a:rPr lang="en-US" sz="4267" b="1" dirty="0">
-                <a:solidFill>
-                  <a:srgbClr val="000066"/>
-                </a:solidFill>
-                <a:effectLst/>
-                <a:latin typeface="Microsoft JhengHei" panose="020B0604030504040204" pitchFamily="34" charset="-120"/>
-                <a:ea typeface="Microsoft JhengHei" panose="020B0604030504040204" pitchFamily="34" charset="-120"/>
-              </a:rPr>
-              <a:t>)</a:t>
+              <a:t> )</a:t>
             </a:r>
             <a:endParaRPr lang="vi-VN" sz="4267" b="1" dirty="0">
               <a:solidFill>
                 <a:srgbClr val="000066"/>
               </a:solidFill>
-              <a:effectLst/>
               <a:ea typeface="Microsoft JhengHei" panose="020B0604030504040204" pitchFamily="34" charset="-120"/>
             </a:endParaRPr>
           </a:p>
@@ -4273,27 +4259,7 @@
                 <a:latin typeface="微軟正黑體" pitchFamily="34" charset="-120"/>
                 <a:ea typeface="微軟正黑體" pitchFamily="34" charset="-120"/>
               </a:rPr>
-              <a:t>不論環境順</a:t>
-            </a:r>
-            <a:r>
-              <a:rPr lang="zh-TW" altLang="en-US" sz="6400" b="1" dirty="0">
-                <a:solidFill>
-                  <a:srgbClr val="000066"/>
-                </a:solidFill>
-                <a:latin typeface="微軟正黑體" pitchFamily="34" charset="-120"/>
-                <a:ea typeface="微軟正黑體" pitchFamily="34" charset="-120"/>
-              </a:rPr>
-              <a:t>逆  我</a:t>
-            </a:r>
-            <a:r>
-              <a:rPr lang="zh-TW" altLang="en-US" sz="6400" b="1" dirty="0">
-                <a:solidFill>
-                  <a:srgbClr val="000066"/>
-                </a:solidFill>
-                <a:latin typeface="微軟正黑體" pitchFamily="34" charset="-120"/>
-                <a:ea typeface="微軟正黑體" pitchFamily="34" charset="-120"/>
-              </a:rPr>
-              <a:t>深深相信</a:t>
+              <a:t>不論環境順逆  我深深相信</a:t>
             </a:r>
             <a:endParaRPr lang="en-US" altLang="zh-CN" sz="6400" b="1" dirty="0">
               <a:solidFill>
@@ -4693,49 +4659,35 @@
                 <a:solidFill>
                   <a:srgbClr val="000066"/>
                 </a:solidFill>
-                <a:effectLst/>
                 <a:latin typeface="Microsoft JhengHei" panose="020B0604030504040204" pitchFamily="34" charset="-120"/>
                 <a:ea typeface="Microsoft JhengHei" panose="020B0604030504040204" pitchFamily="34" charset="-120"/>
               </a:rPr>
               <a:t>( </a:t>
             </a:r>
             <a:r>
-              <a:rPr lang="zh-CN" altLang="en-US" sz="4267" b="1" dirty="0" smtClean="0">
+              <a:rPr lang="zh-CN" altLang="en-US" sz="4267" b="1" dirty="0">
                 <a:solidFill>
                   <a:srgbClr val="000066"/>
                 </a:solidFill>
                 <a:latin typeface="Microsoft JhengHei" panose="020B0604030504040204" pitchFamily="34" charset="-120"/>
                 <a:ea typeface="Microsoft JhengHei" panose="020B0604030504040204" pitchFamily="34" charset="-120"/>
               </a:rPr>
-              <a:t>副</a:t>
-            </a:r>
-            <a:r>
-              <a:rPr lang="en-US" sz="4267" b="1" dirty="0" smtClean="0">
+              <a:t>副歌</a:t>
+            </a:r>
+            <a:r>
+              <a:rPr lang="en-US" sz="4267" b="1" dirty="0">
                 <a:solidFill>
                   <a:srgbClr val="000066"/>
                 </a:solidFill>
-                <a:effectLst/>
                 <a:latin typeface="Microsoft JhengHei" panose="020B0604030504040204" pitchFamily="34" charset="-120"/>
                 <a:ea typeface="Microsoft JhengHei" panose="020B0604030504040204" pitchFamily="34" charset="-120"/>
               </a:rPr>
-              <a:t> </a:t>
-            </a:r>
-            <a:r>
-              <a:rPr lang="en-US" sz="4267" b="1" dirty="0">
-                <a:solidFill>
-                  <a:srgbClr val="000066"/>
-                </a:solidFill>
-                <a:effectLst/>
-                <a:latin typeface="Microsoft JhengHei" panose="020B0604030504040204" pitchFamily="34" charset="-120"/>
-                <a:ea typeface="Microsoft JhengHei" panose="020B0604030504040204" pitchFamily="34" charset="-120"/>
-              </a:rPr>
-              <a:t>)</a:t>
+              <a:t> )</a:t>
             </a:r>
             <a:endParaRPr lang="vi-VN" sz="4267" b="1" dirty="0">
               <a:solidFill>
                 <a:srgbClr val="000066"/>
               </a:solidFill>
-              <a:effectLst/>
               <a:ea typeface="Microsoft JhengHei" panose="020B0604030504040204" pitchFamily="34" charset="-120"/>
             </a:endParaRPr>
           </a:p>
@@ -4987,18 +4939,7 @@
                 <a:ea typeface="微軟正黑體" pitchFamily="34" charset="-120"/>
                 <a:cs typeface="Calibri" panose="020F0502020204030204" pitchFamily="34" charset="0"/>
               </a:rPr>
-              <a:t>Â</a:t>
-            </a:r>
-            <a:r>
-              <a:rPr lang="en-US" sz="4400" b="1" dirty="0" err="1">
-                <a:solidFill>
-                  <a:srgbClr val="660033"/>
-                </a:solidFill>
-                <a:latin typeface="Calibri" panose="020F0502020204030204" pitchFamily="34" charset="0"/>
-                <a:ea typeface="微軟正黑體" pitchFamily="34" charset="-120"/>
-                <a:cs typeface="Calibri" panose="020F0502020204030204" pitchFamily="34" charset="0"/>
-              </a:rPr>
-              <a:t>n</a:t>
+              <a:t>Ân</a:t>
             </a:r>
             <a:r>
               <a:rPr lang="en-US" sz="4400" b="1" dirty="0">
@@ -5171,49 +5112,35 @@
                 <a:solidFill>
                   <a:srgbClr val="000066"/>
                 </a:solidFill>
-                <a:effectLst/>
                 <a:latin typeface="Microsoft JhengHei" panose="020B0604030504040204" pitchFamily="34" charset="-120"/>
                 <a:ea typeface="Microsoft JhengHei" panose="020B0604030504040204" pitchFamily="34" charset="-120"/>
               </a:rPr>
               <a:t>( </a:t>
             </a:r>
             <a:r>
-              <a:rPr lang="zh-CN" altLang="en-US" sz="4267" b="1" dirty="0" smtClean="0">
+              <a:rPr lang="zh-CN" altLang="en-US" sz="4267" b="1" dirty="0">
                 <a:solidFill>
                   <a:srgbClr val="000066"/>
                 </a:solidFill>
                 <a:latin typeface="Microsoft JhengHei" panose="020B0604030504040204" pitchFamily="34" charset="-120"/>
                 <a:ea typeface="Microsoft JhengHei" panose="020B0604030504040204" pitchFamily="34" charset="-120"/>
               </a:rPr>
-              <a:t>副</a:t>
-            </a:r>
-            <a:r>
-              <a:rPr lang="en-US" sz="4267" b="1" dirty="0" smtClean="0">
+              <a:t>副歌</a:t>
+            </a:r>
+            <a:r>
+              <a:rPr lang="en-US" sz="4267" b="1" dirty="0">
                 <a:solidFill>
                   <a:srgbClr val="000066"/>
                 </a:solidFill>
-                <a:effectLst/>
                 <a:latin typeface="Microsoft JhengHei" panose="020B0604030504040204" pitchFamily="34" charset="-120"/>
                 <a:ea typeface="Microsoft JhengHei" panose="020B0604030504040204" pitchFamily="34" charset="-120"/>
               </a:rPr>
-              <a:t> </a:t>
-            </a:r>
-            <a:r>
-              <a:rPr lang="en-US" sz="4267" b="1" dirty="0">
-                <a:solidFill>
-                  <a:srgbClr val="000066"/>
-                </a:solidFill>
-                <a:effectLst/>
-                <a:latin typeface="Microsoft JhengHei" panose="020B0604030504040204" pitchFamily="34" charset="-120"/>
-                <a:ea typeface="Microsoft JhengHei" panose="020B0604030504040204" pitchFamily="34" charset="-120"/>
-              </a:rPr>
-              <a:t>)</a:t>
+              <a:t> )</a:t>
             </a:r>
             <a:endParaRPr lang="vi-VN" sz="4267" b="1" dirty="0">
               <a:solidFill>
                 <a:srgbClr val="000066"/>
               </a:solidFill>
-              <a:effectLst/>
               <a:ea typeface="Microsoft JhengHei" panose="020B0604030504040204" pitchFamily="34" charset="-120"/>
             </a:endParaRPr>
           </a:p>
@@ -5594,49 +5521,35 @@
                 <a:solidFill>
                   <a:srgbClr val="000066"/>
                 </a:solidFill>
-                <a:effectLst/>
                 <a:latin typeface="Microsoft JhengHei" panose="020B0604030504040204" pitchFamily="34" charset="-120"/>
                 <a:ea typeface="Microsoft JhengHei" panose="020B0604030504040204" pitchFamily="34" charset="-120"/>
               </a:rPr>
               <a:t>( </a:t>
             </a:r>
             <a:r>
-              <a:rPr lang="zh-CN" altLang="en-US" sz="4267" b="1" dirty="0" smtClean="0">
+              <a:rPr lang="zh-CN" altLang="en-US" sz="4267" b="1" dirty="0">
                 <a:solidFill>
                   <a:srgbClr val="000066"/>
                 </a:solidFill>
                 <a:latin typeface="Microsoft JhengHei" panose="020B0604030504040204" pitchFamily="34" charset="-120"/>
                 <a:ea typeface="Microsoft JhengHei" panose="020B0604030504040204" pitchFamily="34" charset="-120"/>
               </a:rPr>
-              <a:t>副</a:t>
-            </a:r>
-            <a:r>
-              <a:rPr lang="en-US" sz="4267" b="1" dirty="0" smtClean="0">
+              <a:t>副歌</a:t>
+            </a:r>
+            <a:r>
+              <a:rPr lang="en-US" sz="4267" b="1" dirty="0">
                 <a:solidFill>
                   <a:srgbClr val="000066"/>
                 </a:solidFill>
-                <a:effectLst/>
                 <a:latin typeface="Microsoft JhengHei" panose="020B0604030504040204" pitchFamily="34" charset="-120"/>
                 <a:ea typeface="Microsoft JhengHei" panose="020B0604030504040204" pitchFamily="34" charset="-120"/>
               </a:rPr>
-              <a:t> </a:t>
-            </a:r>
-            <a:r>
-              <a:rPr lang="en-US" sz="4267" b="1" dirty="0">
-                <a:solidFill>
-                  <a:srgbClr val="000066"/>
-                </a:solidFill>
-                <a:effectLst/>
-                <a:latin typeface="Microsoft JhengHei" panose="020B0604030504040204" pitchFamily="34" charset="-120"/>
-                <a:ea typeface="Microsoft JhengHei" panose="020B0604030504040204" pitchFamily="34" charset="-120"/>
-              </a:rPr>
-              <a:t>)</a:t>
+              <a:t> )</a:t>
             </a:r>
             <a:endParaRPr lang="vi-VN" sz="4267" b="1" dirty="0">
               <a:solidFill>
                 <a:srgbClr val="000066"/>
               </a:solidFill>
-              <a:effectLst/>
               <a:ea typeface="Microsoft JhengHei" panose="020B0604030504040204" pitchFamily="34" charset="-120"/>
             </a:endParaRPr>
           </a:p>
@@ -6083,49 +5996,35 @@
                 <a:solidFill>
                   <a:srgbClr val="000066"/>
                 </a:solidFill>
-                <a:effectLst/>
                 <a:latin typeface="Microsoft JhengHei" panose="020B0604030504040204" pitchFamily="34" charset="-120"/>
                 <a:ea typeface="Microsoft JhengHei" panose="020B0604030504040204" pitchFamily="34" charset="-120"/>
               </a:rPr>
               <a:t>( </a:t>
             </a:r>
             <a:r>
-              <a:rPr lang="zh-CN" altLang="en-US" sz="4267" b="1" dirty="0" smtClean="0">
+              <a:rPr lang="zh-CN" altLang="en-US" sz="4267" b="1" dirty="0">
                 <a:solidFill>
                   <a:srgbClr val="000066"/>
                 </a:solidFill>
                 <a:latin typeface="Microsoft JhengHei" panose="020B0604030504040204" pitchFamily="34" charset="-120"/>
                 <a:ea typeface="Microsoft JhengHei" panose="020B0604030504040204" pitchFamily="34" charset="-120"/>
               </a:rPr>
-              <a:t>副</a:t>
-            </a:r>
-            <a:r>
-              <a:rPr lang="en-US" sz="4267" b="1" dirty="0" smtClean="0">
+              <a:t>副歌</a:t>
+            </a:r>
+            <a:r>
+              <a:rPr lang="en-US" sz="4267" b="1" dirty="0">
                 <a:solidFill>
                   <a:srgbClr val="000066"/>
                 </a:solidFill>
-                <a:effectLst/>
                 <a:latin typeface="Microsoft JhengHei" panose="020B0604030504040204" pitchFamily="34" charset="-120"/>
                 <a:ea typeface="Microsoft JhengHei" panose="020B0604030504040204" pitchFamily="34" charset="-120"/>
               </a:rPr>
-              <a:t> </a:t>
-            </a:r>
-            <a:r>
-              <a:rPr lang="en-US" sz="4267" b="1" dirty="0">
-                <a:solidFill>
-                  <a:srgbClr val="000066"/>
-                </a:solidFill>
-                <a:effectLst/>
-                <a:latin typeface="Microsoft JhengHei" panose="020B0604030504040204" pitchFamily="34" charset="-120"/>
-                <a:ea typeface="Microsoft JhengHei" panose="020B0604030504040204" pitchFamily="34" charset="-120"/>
-              </a:rPr>
-              <a:t>)</a:t>
+              <a:t> )</a:t>
             </a:r>
             <a:endParaRPr lang="vi-VN" sz="4267" b="1" dirty="0">
               <a:solidFill>
                 <a:srgbClr val="000066"/>
               </a:solidFill>
-              <a:effectLst/>
               <a:ea typeface="Microsoft JhengHei" panose="020B0604030504040204" pitchFamily="34" charset="-120"/>
             </a:endParaRPr>
           </a:p>
@@ -6194,27 +6093,7 @@
                 <a:latin typeface="微軟正黑體" pitchFamily="34" charset="-120"/>
                 <a:ea typeface="微軟正黑體" pitchFamily="34" charset="-120"/>
               </a:rPr>
-              <a:t>困難都將過</a:t>
-            </a:r>
-            <a:r>
-              <a:rPr lang="zh-TW" altLang="en-US" sz="6400" b="1" dirty="0">
-                <a:solidFill>
-                  <a:srgbClr val="000066"/>
-                </a:solidFill>
-                <a:latin typeface="微軟正黑體" pitchFamily="34" charset="-120"/>
-                <a:ea typeface="微軟正黑體" pitchFamily="34" charset="-120"/>
-              </a:rPr>
-              <a:t>去  我</a:t>
-            </a:r>
-            <a:r>
-              <a:rPr lang="zh-TW" altLang="en-US" sz="6400" b="1" dirty="0">
-                <a:solidFill>
-                  <a:srgbClr val="000066"/>
-                </a:solidFill>
-                <a:latin typeface="微軟正黑體" pitchFamily="34" charset="-120"/>
-                <a:ea typeface="微軟正黑體" pitchFamily="34" charset="-120"/>
-              </a:rPr>
-              <a:t>靠主站立</a:t>
+              <a:t>困難都將過去  我靠主站立</a:t>
             </a:r>
             <a:endParaRPr lang="en-US" altLang="zh-CN" sz="6400" b="1" dirty="0">
               <a:solidFill>
@@ -6658,49 +6537,35 @@
                 <a:solidFill>
                   <a:srgbClr val="000066"/>
                 </a:solidFill>
-                <a:effectLst/>
                 <a:latin typeface="Microsoft JhengHei" panose="020B0604030504040204" pitchFamily="34" charset="-120"/>
                 <a:ea typeface="Microsoft JhengHei" panose="020B0604030504040204" pitchFamily="34" charset="-120"/>
               </a:rPr>
               <a:t>( </a:t>
             </a:r>
             <a:r>
-              <a:rPr lang="zh-CN" altLang="en-US" sz="4267" b="1" dirty="0" smtClean="0">
+              <a:rPr lang="zh-CN" altLang="en-US" sz="4267" b="1" dirty="0">
                 <a:solidFill>
                   <a:srgbClr val="000066"/>
                 </a:solidFill>
                 <a:latin typeface="Microsoft JhengHei" panose="020B0604030504040204" pitchFamily="34" charset="-120"/>
                 <a:ea typeface="Microsoft JhengHei" panose="020B0604030504040204" pitchFamily="34" charset="-120"/>
               </a:rPr>
-              <a:t>副</a:t>
-            </a:r>
-            <a:r>
-              <a:rPr lang="en-US" sz="4267" b="1" dirty="0" smtClean="0">
+              <a:t>副歌</a:t>
+            </a:r>
+            <a:r>
+              <a:rPr lang="en-US" sz="4267" b="1" dirty="0">
                 <a:solidFill>
                   <a:srgbClr val="000066"/>
                 </a:solidFill>
-                <a:effectLst/>
                 <a:latin typeface="Microsoft JhengHei" panose="020B0604030504040204" pitchFamily="34" charset="-120"/>
                 <a:ea typeface="Microsoft JhengHei" panose="020B0604030504040204" pitchFamily="34" charset="-120"/>
               </a:rPr>
-              <a:t> </a:t>
-            </a:r>
-            <a:r>
-              <a:rPr lang="en-US" sz="4267" b="1" dirty="0">
-                <a:solidFill>
-                  <a:srgbClr val="000066"/>
-                </a:solidFill>
-                <a:effectLst/>
-                <a:latin typeface="Microsoft JhengHei" panose="020B0604030504040204" pitchFamily="34" charset="-120"/>
-                <a:ea typeface="Microsoft JhengHei" panose="020B0604030504040204" pitchFamily="34" charset="-120"/>
-              </a:rPr>
-              <a:t>)</a:t>
+              <a:t> )</a:t>
             </a:r>
             <a:endParaRPr lang="vi-VN" sz="4267" b="1" dirty="0">
               <a:solidFill>
                 <a:srgbClr val="000066"/>
               </a:solidFill>
-              <a:effectLst/>
               <a:ea typeface="Microsoft JhengHei" panose="020B0604030504040204" pitchFamily="34" charset="-120"/>
             </a:endParaRPr>
           </a:p>
@@ -7103,49 +6968,35 @@
                 <a:solidFill>
                   <a:srgbClr val="000066"/>
                 </a:solidFill>
-                <a:effectLst/>
                 <a:latin typeface="Microsoft JhengHei" panose="020B0604030504040204" pitchFamily="34" charset="-120"/>
                 <a:ea typeface="Microsoft JhengHei" panose="020B0604030504040204" pitchFamily="34" charset="-120"/>
               </a:rPr>
               <a:t>( </a:t>
             </a:r>
             <a:r>
-              <a:rPr lang="zh-CN" altLang="en-US" sz="4267" b="1" dirty="0" smtClean="0">
+              <a:rPr lang="zh-CN" altLang="en-US" sz="4267" b="1" dirty="0">
                 <a:solidFill>
                   <a:srgbClr val="000066"/>
                 </a:solidFill>
                 <a:latin typeface="Microsoft JhengHei" panose="020B0604030504040204" pitchFamily="34" charset="-120"/>
                 <a:ea typeface="Microsoft JhengHei" panose="020B0604030504040204" pitchFamily="34" charset="-120"/>
               </a:rPr>
-              <a:t>副</a:t>
-            </a:r>
-            <a:r>
-              <a:rPr lang="en-US" sz="4267" b="1" dirty="0" smtClean="0">
+              <a:t>副歌</a:t>
+            </a:r>
+            <a:r>
+              <a:rPr lang="en-US" sz="4267" b="1" dirty="0">
                 <a:solidFill>
                   <a:srgbClr val="000066"/>
                 </a:solidFill>
-                <a:effectLst/>
                 <a:latin typeface="Microsoft JhengHei" panose="020B0604030504040204" pitchFamily="34" charset="-120"/>
                 <a:ea typeface="Microsoft JhengHei" panose="020B0604030504040204" pitchFamily="34" charset="-120"/>
               </a:rPr>
-              <a:t> </a:t>
-            </a:r>
-            <a:r>
-              <a:rPr lang="en-US" sz="4267" b="1" dirty="0">
-                <a:solidFill>
-                  <a:srgbClr val="000066"/>
-                </a:solidFill>
-                <a:effectLst/>
-                <a:latin typeface="Microsoft JhengHei" panose="020B0604030504040204" pitchFamily="34" charset="-120"/>
-                <a:ea typeface="Microsoft JhengHei" panose="020B0604030504040204" pitchFamily="34" charset="-120"/>
-              </a:rPr>
-              <a:t>)</a:t>
+              <a:t> )</a:t>
             </a:r>
             <a:endParaRPr lang="vi-VN" sz="4267" b="1" dirty="0">
               <a:solidFill>
                 <a:srgbClr val="000066"/>
               </a:solidFill>
-              <a:effectLst/>
               <a:ea typeface="Microsoft JhengHei" panose="020B0604030504040204" pitchFamily="34" charset="-120"/>
             </a:endParaRPr>
           </a:p>
@@ -7224,17 +7075,7 @@
                 <a:latin typeface="微軟正黑體" pitchFamily="34" charset="-120"/>
                 <a:ea typeface="微軟正黑體" pitchFamily="34" charset="-120"/>
               </a:rPr>
-              <a:t>過主恩的滋</a:t>
-            </a:r>
-            <a:r>
-              <a:rPr lang="zh-TW" altLang="en-US" sz="6400" b="1" dirty="0">
-                <a:solidFill>
-                  <a:srgbClr val="000066"/>
-                </a:solidFill>
-                <a:latin typeface="微軟正黑體" pitchFamily="34" charset="-120"/>
-                <a:ea typeface="微軟正黑體" pitchFamily="34" charset="-120"/>
-              </a:rPr>
-              <a:t>味</a:t>
+              <a:t>過主恩的滋味</a:t>
             </a:r>
             <a:endParaRPr lang="en-US" altLang="zh-CN" sz="6400" b="1" dirty="0">
               <a:solidFill>
@@ -7556,14 +7397,14 @@
               <a:t>( </a:t>
             </a:r>
             <a:r>
-              <a:rPr lang="zh-CN" altLang="en-US" sz="4267" b="1" dirty="0">
+              <a:rPr lang="zh-CN" altLang="en-US" sz="4267" b="1" dirty="0" smtClean="0">
                 <a:solidFill>
                   <a:srgbClr val="000066"/>
                 </a:solidFill>
                 <a:latin typeface="Microsoft JhengHei" panose="020B0604030504040204" pitchFamily="34" charset="-120"/>
                 <a:ea typeface="Microsoft JhengHei" panose="020B0604030504040204" pitchFamily="34" charset="-120"/>
               </a:rPr>
-              <a:t>正</a:t>
+              <a:t>正歌</a:t>
             </a:r>
             <a:r>
               <a:rPr lang="en-US" sz="4267" b="1" dirty="0" smtClean="0">
@@ -8004,7 +7845,6 @@
                 <a:solidFill>
                   <a:srgbClr val="000066"/>
                 </a:solidFill>
-                <a:effectLst/>
                 <a:latin typeface="Microsoft JhengHei" panose="020B0604030504040204" pitchFamily="34" charset="-120"/>
                 <a:ea typeface="Microsoft JhengHei" panose="020B0604030504040204" pitchFamily="34" charset="-120"/>
               </a:rPr>
@@ -8018,35 +7858,22 @@
                 <a:latin typeface="Microsoft JhengHei" panose="020B0604030504040204" pitchFamily="34" charset="-120"/>
                 <a:ea typeface="Microsoft JhengHei" panose="020B0604030504040204" pitchFamily="34" charset="-120"/>
               </a:rPr>
-              <a:t>正</a:t>
-            </a:r>
-            <a:r>
-              <a:rPr lang="en-US" sz="4267" b="1" dirty="0" smtClean="0">
+              <a:t>正歌</a:t>
+            </a:r>
+            <a:r>
+              <a:rPr lang="en-US" sz="4267" b="1" dirty="0">
                 <a:solidFill>
                   <a:srgbClr val="000066"/>
                 </a:solidFill>
-                <a:effectLst/>
                 <a:latin typeface="Microsoft JhengHei" panose="020B0604030504040204" pitchFamily="34" charset="-120"/>
                 <a:ea typeface="Microsoft JhengHei" panose="020B0604030504040204" pitchFamily="34" charset="-120"/>
               </a:rPr>
-              <a:t> </a:t>
-            </a:r>
-            <a:r>
-              <a:rPr lang="en-US" sz="4267" b="1" dirty="0">
-                <a:solidFill>
-                  <a:srgbClr val="000066"/>
-                </a:solidFill>
-                <a:effectLst/>
-                <a:latin typeface="Microsoft JhengHei" panose="020B0604030504040204" pitchFamily="34" charset="-120"/>
-                <a:ea typeface="Microsoft JhengHei" panose="020B0604030504040204" pitchFamily="34" charset="-120"/>
-              </a:rPr>
-              <a:t>)</a:t>
+              <a:t> )</a:t>
             </a:r>
             <a:endParaRPr lang="vi-VN" sz="4267" b="1" dirty="0">
               <a:solidFill>
                 <a:srgbClr val="000066"/>
               </a:solidFill>
-              <a:effectLst/>
               <a:ea typeface="Microsoft JhengHei" panose="020B0604030504040204" pitchFamily="34" charset="-120"/>
             </a:endParaRPr>
           </a:p>
@@ -8449,7 +8276,6 @@
                 <a:solidFill>
                   <a:srgbClr val="000066"/>
                 </a:solidFill>
-                <a:effectLst/>
                 <a:latin typeface="Microsoft JhengHei" panose="020B0604030504040204" pitchFamily="34" charset="-120"/>
                 <a:ea typeface="Microsoft JhengHei" panose="020B0604030504040204" pitchFamily="34" charset="-120"/>
               </a:rPr>
@@ -8463,35 +8289,22 @@
                 <a:latin typeface="Microsoft JhengHei" panose="020B0604030504040204" pitchFamily="34" charset="-120"/>
                 <a:ea typeface="Microsoft JhengHei" panose="020B0604030504040204" pitchFamily="34" charset="-120"/>
               </a:rPr>
-              <a:t>正</a:t>
-            </a:r>
-            <a:r>
-              <a:rPr lang="en-US" sz="4267" b="1" dirty="0" smtClean="0">
+              <a:t>正歌</a:t>
+            </a:r>
+            <a:r>
+              <a:rPr lang="en-US" sz="4267" b="1" dirty="0">
                 <a:solidFill>
                   <a:srgbClr val="000066"/>
                 </a:solidFill>
-                <a:effectLst/>
                 <a:latin typeface="Microsoft JhengHei" panose="020B0604030504040204" pitchFamily="34" charset="-120"/>
                 <a:ea typeface="Microsoft JhengHei" panose="020B0604030504040204" pitchFamily="34" charset="-120"/>
               </a:rPr>
-              <a:t> </a:t>
-            </a:r>
-            <a:r>
-              <a:rPr lang="en-US" sz="4267" b="1" dirty="0">
-                <a:solidFill>
-                  <a:srgbClr val="000066"/>
-                </a:solidFill>
-                <a:effectLst/>
-                <a:latin typeface="Microsoft JhengHei" panose="020B0604030504040204" pitchFamily="34" charset="-120"/>
-                <a:ea typeface="Microsoft JhengHei" panose="020B0604030504040204" pitchFamily="34" charset="-120"/>
-              </a:rPr>
-              <a:t>)</a:t>
+              <a:t> )</a:t>
             </a:r>
             <a:endParaRPr lang="vi-VN" sz="4267" b="1" dirty="0">
               <a:solidFill>
                 <a:srgbClr val="000066"/>
               </a:solidFill>
-              <a:effectLst/>
               <a:ea typeface="Microsoft JhengHei" panose="020B0604030504040204" pitchFamily="34" charset="-120"/>
             </a:endParaRPr>
           </a:p>
@@ -8894,7 +8707,6 @@
                 <a:solidFill>
                   <a:srgbClr val="000066"/>
                 </a:solidFill>
-                <a:effectLst/>
                 <a:latin typeface="Microsoft JhengHei" panose="020B0604030504040204" pitchFamily="34" charset="-120"/>
                 <a:ea typeface="Microsoft JhengHei" panose="020B0604030504040204" pitchFamily="34" charset="-120"/>
               </a:rPr>
@@ -8908,35 +8720,22 @@
                 <a:latin typeface="Microsoft JhengHei" panose="020B0604030504040204" pitchFamily="34" charset="-120"/>
                 <a:ea typeface="Microsoft JhengHei" panose="020B0604030504040204" pitchFamily="34" charset="-120"/>
               </a:rPr>
-              <a:t>正</a:t>
-            </a:r>
-            <a:r>
-              <a:rPr lang="en-US" sz="4267" b="1" dirty="0" smtClean="0">
+              <a:t>正歌</a:t>
+            </a:r>
+            <a:r>
+              <a:rPr lang="en-US" sz="4267" b="1" dirty="0">
                 <a:solidFill>
                   <a:srgbClr val="000066"/>
                 </a:solidFill>
-                <a:effectLst/>
                 <a:latin typeface="Microsoft JhengHei" panose="020B0604030504040204" pitchFamily="34" charset="-120"/>
                 <a:ea typeface="Microsoft JhengHei" panose="020B0604030504040204" pitchFamily="34" charset="-120"/>
               </a:rPr>
-              <a:t> </a:t>
-            </a:r>
-            <a:r>
-              <a:rPr lang="en-US" sz="4267" b="1" dirty="0">
-                <a:solidFill>
-                  <a:srgbClr val="000066"/>
-                </a:solidFill>
-                <a:effectLst/>
-                <a:latin typeface="Microsoft JhengHei" panose="020B0604030504040204" pitchFamily="34" charset="-120"/>
-                <a:ea typeface="Microsoft JhengHei" panose="020B0604030504040204" pitchFamily="34" charset="-120"/>
-              </a:rPr>
-              <a:t>)</a:t>
+              <a:t> )</a:t>
             </a:r>
             <a:endParaRPr lang="vi-VN" sz="4267" b="1" dirty="0">
               <a:solidFill>
                 <a:srgbClr val="000066"/>
               </a:solidFill>
-              <a:effectLst/>
               <a:ea typeface="Microsoft JhengHei" panose="020B0604030504040204" pitchFamily="34" charset="-120"/>
             </a:endParaRPr>
           </a:p>
@@ -9361,7 +9160,6 @@
                 <a:solidFill>
                   <a:srgbClr val="000066"/>
                 </a:solidFill>
-                <a:effectLst/>
                 <a:latin typeface="Microsoft JhengHei" panose="020B0604030504040204" pitchFamily="34" charset="-120"/>
                 <a:ea typeface="Microsoft JhengHei" panose="020B0604030504040204" pitchFamily="34" charset="-120"/>
               </a:rPr>
@@ -9375,35 +9173,22 @@
                 <a:latin typeface="Microsoft JhengHei" panose="020B0604030504040204" pitchFamily="34" charset="-120"/>
                 <a:ea typeface="Microsoft JhengHei" panose="020B0604030504040204" pitchFamily="34" charset="-120"/>
               </a:rPr>
-              <a:t>正</a:t>
-            </a:r>
-            <a:r>
-              <a:rPr lang="en-US" sz="4267" b="1" dirty="0" smtClean="0">
+              <a:t>正歌</a:t>
+            </a:r>
+            <a:r>
+              <a:rPr lang="en-US" sz="4267" b="1" dirty="0">
                 <a:solidFill>
                   <a:srgbClr val="000066"/>
                 </a:solidFill>
-                <a:effectLst/>
                 <a:latin typeface="Microsoft JhengHei" panose="020B0604030504040204" pitchFamily="34" charset="-120"/>
                 <a:ea typeface="Microsoft JhengHei" panose="020B0604030504040204" pitchFamily="34" charset="-120"/>
               </a:rPr>
-              <a:t> </a:t>
-            </a:r>
-            <a:r>
-              <a:rPr lang="en-US" sz="4267" b="1" dirty="0">
-                <a:solidFill>
-                  <a:srgbClr val="000066"/>
-                </a:solidFill>
-                <a:effectLst/>
-                <a:latin typeface="Microsoft JhengHei" panose="020B0604030504040204" pitchFamily="34" charset="-120"/>
-                <a:ea typeface="Microsoft JhengHei" panose="020B0604030504040204" pitchFamily="34" charset="-120"/>
-              </a:rPr>
-              <a:t>)</a:t>
+              <a:t> )</a:t>
             </a:r>
             <a:endParaRPr lang="vi-VN" sz="4267" b="1" dirty="0">
               <a:solidFill>
                 <a:srgbClr val="000066"/>
               </a:solidFill>
-              <a:effectLst/>
               <a:ea typeface="Microsoft JhengHei" panose="020B0604030504040204" pitchFamily="34" charset="-120"/>
             </a:endParaRPr>
           </a:p>
@@ -9850,7 +9635,6 @@
                 <a:solidFill>
                   <a:srgbClr val="000066"/>
                 </a:solidFill>
-                <a:effectLst/>
                 <a:latin typeface="Microsoft JhengHei" panose="020B0604030504040204" pitchFamily="34" charset="-120"/>
                 <a:ea typeface="Microsoft JhengHei" panose="020B0604030504040204" pitchFamily="34" charset="-120"/>
               </a:rPr>
@@ -9864,35 +9648,22 @@
                 <a:latin typeface="Microsoft JhengHei" panose="020B0604030504040204" pitchFamily="34" charset="-120"/>
                 <a:ea typeface="Microsoft JhengHei" panose="020B0604030504040204" pitchFamily="34" charset="-120"/>
               </a:rPr>
-              <a:t>正</a:t>
-            </a:r>
-            <a:r>
-              <a:rPr lang="en-US" sz="4267" b="1" dirty="0" smtClean="0">
+              <a:t>正歌</a:t>
+            </a:r>
+            <a:r>
+              <a:rPr lang="en-US" sz="4267" b="1" dirty="0">
                 <a:solidFill>
                   <a:srgbClr val="000066"/>
                 </a:solidFill>
-                <a:effectLst/>
                 <a:latin typeface="Microsoft JhengHei" panose="020B0604030504040204" pitchFamily="34" charset="-120"/>
                 <a:ea typeface="Microsoft JhengHei" panose="020B0604030504040204" pitchFamily="34" charset="-120"/>
               </a:rPr>
-              <a:t> </a:t>
-            </a:r>
-            <a:r>
-              <a:rPr lang="en-US" sz="4267" b="1" dirty="0">
-                <a:solidFill>
-                  <a:srgbClr val="000066"/>
-                </a:solidFill>
-                <a:effectLst/>
-                <a:latin typeface="Microsoft JhengHei" panose="020B0604030504040204" pitchFamily="34" charset="-120"/>
-                <a:ea typeface="Microsoft JhengHei" panose="020B0604030504040204" pitchFamily="34" charset="-120"/>
-              </a:rPr>
-              <a:t>)</a:t>
+              <a:t> )</a:t>
             </a:r>
             <a:endParaRPr lang="vi-VN" sz="4267" b="1" dirty="0">
               <a:solidFill>
                 <a:srgbClr val="000066"/>
               </a:solidFill>
-              <a:effectLst/>
               <a:ea typeface="Microsoft JhengHei" panose="020B0604030504040204" pitchFamily="34" charset="-120"/>
             </a:endParaRPr>
           </a:p>
@@ -10295,7 +10066,6 @@
                 <a:solidFill>
                   <a:srgbClr val="000066"/>
                 </a:solidFill>
-                <a:effectLst/>
                 <a:latin typeface="Microsoft JhengHei" panose="020B0604030504040204" pitchFamily="34" charset="-120"/>
                 <a:ea typeface="Microsoft JhengHei" panose="020B0604030504040204" pitchFamily="34" charset="-120"/>
               </a:rPr>
@@ -10309,35 +10079,22 @@
                 <a:latin typeface="Microsoft JhengHei" panose="020B0604030504040204" pitchFamily="34" charset="-120"/>
                 <a:ea typeface="Microsoft JhengHei" panose="020B0604030504040204" pitchFamily="34" charset="-120"/>
               </a:rPr>
-              <a:t>正</a:t>
-            </a:r>
-            <a:r>
-              <a:rPr lang="en-US" sz="4267" b="1" dirty="0" smtClean="0">
+              <a:t>正歌</a:t>
+            </a:r>
+            <a:r>
+              <a:rPr lang="en-US" sz="4267" b="1" dirty="0">
                 <a:solidFill>
                   <a:srgbClr val="000066"/>
                 </a:solidFill>
-                <a:effectLst/>
                 <a:latin typeface="Microsoft JhengHei" panose="020B0604030504040204" pitchFamily="34" charset="-120"/>
                 <a:ea typeface="Microsoft JhengHei" panose="020B0604030504040204" pitchFamily="34" charset="-120"/>
               </a:rPr>
-              <a:t> </a:t>
-            </a:r>
-            <a:r>
-              <a:rPr lang="en-US" sz="4267" b="1" dirty="0">
-                <a:solidFill>
-                  <a:srgbClr val="000066"/>
-                </a:solidFill>
-                <a:effectLst/>
-                <a:latin typeface="Microsoft JhengHei" panose="020B0604030504040204" pitchFamily="34" charset="-120"/>
-                <a:ea typeface="Microsoft JhengHei" panose="020B0604030504040204" pitchFamily="34" charset="-120"/>
-              </a:rPr>
-              <a:t>)</a:t>
+              <a:t> )</a:t>
             </a:r>
             <a:endParaRPr lang="vi-VN" sz="4267" b="1" dirty="0">
               <a:solidFill>
                 <a:srgbClr val="000066"/>
               </a:solidFill>
-              <a:effectLst/>
               <a:ea typeface="Microsoft JhengHei" panose="020B0604030504040204" pitchFamily="34" charset="-120"/>
             </a:endParaRPr>
           </a:p>
@@ -10740,7 +10497,6 @@
                 <a:solidFill>
                   <a:srgbClr val="000066"/>
                 </a:solidFill>
-                <a:effectLst/>
                 <a:latin typeface="Microsoft JhengHei" panose="020B0604030504040204" pitchFamily="34" charset="-120"/>
                 <a:ea typeface="Microsoft JhengHei" panose="020B0604030504040204" pitchFamily="34" charset="-120"/>
               </a:rPr>
@@ -10754,35 +10510,22 @@
                 <a:latin typeface="Microsoft JhengHei" panose="020B0604030504040204" pitchFamily="34" charset="-120"/>
                 <a:ea typeface="Microsoft JhengHei" panose="020B0604030504040204" pitchFamily="34" charset="-120"/>
               </a:rPr>
-              <a:t>正</a:t>
-            </a:r>
-            <a:r>
-              <a:rPr lang="en-US" sz="4267" b="1" dirty="0" smtClean="0">
+              <a:t>正歌</a:t>
+            </a:r>
+            <a:r>
+              <a:rPr lang="en-US" sz="4267" b="1" dirty="0">
                 <a:solidFill>
                   <a:srgbClr val="000066"/>
                 </a:solidFill>
-                <a:effectLst/>
                 <a:latin typeface="Microsoft JhengHei" panose="020B0604030504040204" pitchFamily="34" charset="-120"/>
                 <a:ea typeface="Microsoft JhengHei" panose="020B0604030504040204" pitchFamily="34" charset="-120"/>
               </a:rPr>
-              <a:t> </a:t>
-            </a:r>
-            <a:r>
-              <a:rPr lang="en-US" sz="4267" b="1" dirty="0">
-                <a:solidFill>
-                  <a:srgbClr val="000066"/>
-                </a:solidFill>
-                <a:effectLst/>
-                <a:latin typeface="Microsoft JhengHei" panose="020B0604030504040204" pitchFamily="34" charset="-120"/>
-                <a:ea typeface="Microsoft JhengHei" panose="020B0604030504040204" pitchFamily="34" charset="-120"/>
-              </a:rPr>
-              <a:t>)</a:t>
+              <a:t> )</a:t>
             </a:r>
             <a:endParaRPr lang="vi-VN" sz="4267" b="1" dirty="0">
               <a:solidFill>
                 <a:srgbClr val="000066"/>
               </a:solidFill>
-              <a:effectLst/>
               <a:ea typeface="Microsoft JhengHei" panose="020B0604030504040204" pitchFamily="34" charset="-120"/>
             </a:endParaRPr>
           </a:p>

</xml_diff>